<commit_message>
docs: finalize hackathon submission record
</commit_message>
<xml_diff>
--- a/docs/submission/proofline-pitch.pptx
+++ b/docs/submission/proofline-pitch.pptx
@@ -2925,6 +2925,10 @@
             </a:solidFill>
           </a:ln>
         </p:spPr>
+        <p:txBody xmlns:a="http://schemas.openxmlformats.org/drawingml/2006/main">
+          <a:bodyPr/>
+          <a:p/>
+        </p:txBody>
       </p:sp>
       <p:sp>
         <p:nvSpPr>
@@ -2972,13 +2976,13 @@
             <a:r>
               <a:rPr sz="1800" b="1">
                 <a:solidFill>
-                  <a:srgbClr val="087A54"/>
+                  <a:srgbClr val="A35A00"/>
                 </a:solidFill>
                 <a:latin typeface="Arial"/>
                 <a:ea typeface="Arial"/>
                 <a:cs typeface="Arial"/>
               </a:rPr>
-              <a:t>PROVEN</a:t>
+              <a:t>CONDITIONAL</a:t>
             </a:r>
           </a:p>
         </p:txBody>
@@ -3035,7 +3039,7 @@
                 <a:ea typeface="Arial"/>
                 <a:cs typeface="Arial"/>
               </a:rPr>
-              <a:t>Local contract check passed</a:t>
+              <a:t>A passing result was declared, not run</a:t>
             </a:r>
           </a:p>
         </p:txBody>
@@ -3092,7 +3096,7 @@
                 <a:ea typeface="Arial"/>
                 <a:cs typeface="Arial"/>
               </a:rPr>
-              <a:t>Proven only in the local evidence class.</a:t>
+              <a:t>It stays conditional until the explicit runner observes it.</a:t>
             </a:r>
           </a:p>
         </p:txBody>
@@ -3128,6 +3132,10 @@
             </a:solidFill>
           </a:ln>
         </p:spPr>
+        <p:txBody xmlns:a="http://schemas.openxmlformats.org/drawingml/2006/main">
+          <a:bodyPr/>
+          <a:p/>
+        </p:txBody>
       </p:sp>
       <p:sp>
         <p:nvSpPr>
@@ -3238,7 +3246,7 @@
                 <a:ea typeface="Arial"/>
                 <a:cs typeface="Arial"/>
               </a:rPr>
-              <a:t>Fixture telemetry supplied</a:t>
+              <a:t>Synthetic fixture evidence</a:t>
             </a:r>
           </a:p>
         </p:txBody>
@@ -3331,6 +3339,10 @@
             </a:solidFill>
           </a:ln>
         </p:spPr>
+        <p:txBody xmlns:a="http://schemas.openxmlformats.org/drawingml/2006/main">
+          <a:bodyPr/>
+          <a:p/>
+        </p:txBody>
       </p:sp>
       <p:sp>
         <p:nvSpPr>
@@ -3620,6 +3632,10 @@
             </a:solidFill>
           </a:ln>
         </p:spPr>
+        <p:txBody xmlns:a="http://schemas.openxmlformats.org/drawingml/2006/main">
+          <a:bodyPr/>
+          <a:p/>
+        </p:txBody>
       </p:sp>
       <p:sp>
         <p:nvSpPr>
@@ -4015,7 +4031,7 @@
                 <a:ea typeface="Arial"/>
                 <a:cs typeface="Arial"/>
               </a:rPr>
-              <a:t>Unknown IDs are blocked. There is no network or provider call in the demo.</a:t>
+              <a:t>Unknown IDs are blocked. The demo calls no external AI provider.</a:t>
             </a:r>
           </a:p>
         </p:txBody>
@@ -4051,6 +4067,10 @@
             </a:solidFill>
           </a:ln>
         </p:spPr>
+        <p:txBody xmlns:a="http://schemas.openxmlformats.org/drawingml/2006/main">
+          <a:bodyPr/>
+          <a:p/>
+        </p:txBody>
       </p:sp>
       <p:sp>
         <p:nvSpPr>
@@ -4226,6 +4246,10 @@
             </a:solidFill>
           </a:ln>
         </p:spPr>
+        <p:txBody xmlns:a="http://schemas.openxmlformats.org/drawingml/2006/main">
+          <a:bodyPr/>
+          <a:p/>
+        </p:txBody>
       </p:sp>
       <p:sp>
         <p:nvSpPr>
@@ -4486,6 +4510,10 @@
             </a:solidFill>
           </a:ln>
         </p:spPr>
+        <p:txBody xmlns:a="http://schemas.openxmlformats.org/drawingml/2006/main">
+          <a:bodyPr/>
+          <a:p/>
+        </p:txBody>
       </p:sp>
       <p:sp>
         <p:nvSpPr>
@@ -4539,7 +4567,7 @@
                 <a:ea typeface="Arial"/>
                 <a:cs typeface="Arial"/>
               </a:rPr>
-              <a:t>100 local tests passed</a:t>
+              <a:t>106 local tests passed</a:t>
             </a:r>
           </a:p>
         </p:txBody>
@@ -4596,7 +4624,7 @@
                 <a:ea typeface="Arial"/>
                 <a:cs typeface="Arial"/>
               </a:rPr>
-              <a:t>HTML report reviewed by the user in a browser</a:t>
+              <a:t>All three synthetic states reviewed in a local browser</a:t>
             </a:r>
           </a:p>
         </p:txBody>
@@ -4653,7 +4681,7 @@
                 <a:ea typeface="Arial"/>
                 <a:cs typeface="Arial"/>
               </a:rPr>
-              <a:t>Bob task-session exports must accompany the public submission.</a:t>
+              <a:t>Redacted Bob history and summary screenshot are included in the repository.</a:t>
             </a:r>
           </a:p>
         </p:txBody>
@@ -4775,6 +4803,10 @@
             </a:solidFill>
           </a:ln>
         </p:spPr>
+        <p:txBody xmlns:a="http://schemas.openxmlformats.org/drawingml/2006/main">
+          <a:bodyPr/>
+          <a:p/>
+        </p:txBody>
       </p:sp>
       <p:sp>
         <p:nvSpPr>
@@ -4828,7 +4860,7 @@
                 <a:ea typeface="Arial"/>
                 <a:cs typeface="Arial"/>
               </a:rPr>
-              <a:t>Proved locally</a:t>
+              <a:t>Verified locally</a:t>
             </a:r>
           </a:p>
         </p:txBody>
@@ -4885,7 +4917,7 @@
                 <a:ea typeface="Arial"/>
                 <a:cs typeface="Arial"/>
               </a:rPr>
-              <a:t>Manifest validation, status calculation, safe report rendering, and the registered local check.</a:t>
+              <a:t>Manifest validation, 106-test verification, safe reports, and an allowlisted local check.</a:t>
             </a:r>
           </a:p>
         </p:txBody>
@@ -4942,7 +4974,7 @@
                 <a:ea typeface="Arial"/>
                 <a:cs typeface="Arial"/>
               </a:rPr>
-              <a:t>Still needs evidence</a:t>
+              <a:t>Observed in the hosted demo</a:t>
             </a:r>
           </a:p>
         </p:txBody>
@@ -4999,7 +5031,7 @@
                 <a:ea typeface="Arial"/>
                 <a:cs typeface="Arial"/>
               </a:rPr>
-              <a:t>Public demo access, hosted behavior, provider behavior, and any production claim.</a:t>
+              <a:t>A live synthetic case remained conditional; no commands ran.</a:t>
             </a:r>
           </a:p>
         </p:txBody>
@@ -5035,6 +5067,10 @@
             </a:solidFill>
           </a:ln>
         </p:spPr>
+        <p:txBody xmlns:a="http://schemas.openxmlformats.org/drawingml/2006/main">
+          <a:bodyPr/>
+          <a:p/>
+        </p:txBody>
       </p:sp>
       <p:sp>
         <p:nvSpPr>
@@ -5080,7 +5116,7 @@
               </a:defRPr>
             </a:pPr>
             <a:r>
-              <a:rPr sz="2250" b="1">
+              <a:rPr sz="1800" b="1">
                 <a:solidFill>
                   <a:srgbClr val="11263D"/>
                 </a:solidFill>
@@ -5088,7 +5124,7 @@
                 <a:ea typeface="Arial"/>
                 <a:cs typeface="Arial"/>
               </a:rPr>
-              <a:t>Submission needs a live prototype, public repository, video, and PDF deck.</a:t>
+              <a:t>Still unverified: providers, private-data protections, and production readiness.</a:t>
             </a:r>
           </a:p>
         </p:txBody>
@@ -5137,7 +5173,7 @@
               </a:defRPr>
             </a:pPr>
             <a:r>
-              <a:rPr sz="1800" b="0">
+              <a:rPr sz="1500" b="0">
                 <a:solidFill>
                   <a:srgbClr val="52677B"/>
                 </a:solidFill>
@@ -5145,7 +5181,7 @@
                 <a:ea typeface="Arial"/>
                 <a:cs typeface="Arial"/>
               </a:rPr>
-              <a:t>No hosted URL, Bob export, or submission is claimed here.</a:t>
+              <a:t>Live demo: https://proofline-ibm-g27i974jq-shaurya-s-projects11.vercel.app</a:t>
             </a:r>
           </a:p>
         </p:txBody>

</xml_diff>

<commit_message>
Complete Proofline prototype and submission preparation
Finish the Proofline prototype and submission package, align status documentation with the published Lablab entry, and include the final deck and demo video.
</commit_message>
<xml_diff>
--- a/docs/submission/proofline-pitch.pptx
+++ b/docs/submission/proofline-pitch.pptx
@@ -2925,6 +2925,10 @@
             </a:solidFill>
           </a:ln>
         </p:spPr>
+        <p:txBody xmlns:a="http://schemas.openxmlformats.org/drawingml/2006/main">
+          <a:bodyPr/>
+          <a:p/>
+        </p:txBody>
       </p:sp>
       <p:sp>
         <p:nvSpPr>
@@ -2972,13 +2976,13 @@
             <a:r>
               <a:rPr sz="1800" b="1">
                 <a:solidFill>
-                  <a:srgbClr val="087A54"/>
+                  <a:srgbClr val="A35A00"/>
                 </a:solidFill>
                 <a:latin typeface="Arial"/>
                 <a:ea typeface="Arial"/>
                 <a:cs typeface="Arial"/>
               </a:rPr>
-              <a:t>PROVEN</a:t>
+              <a:t>CONDITIONAL</a:t>
             </a:r>
           </a:p>
         </p:txBody>
@@ -3035,7 +3039,7 @@
                 <a:ea typeface="Arial"/>
                 <a:cs typeface="Arial"/>
               </a:rPr>
-              <a:t>Local contract check passed</a:t>
+              <a:t>A passing result was declared, not run</a:t>
             </a:r>
           </a:p>
         </p:txBody>
@@ -3092,7 +3096,7 @@
                 <a:ea typeface="Arial"/>
                 <a:cs typeface="Arial"/>
               </a:rPr>
-              <a:t>Proven only in the local evidence class.</a:t>
+              <a:t>It stays conditional until the explicit runner observes it.</a:t>
             </a:r>
           </a:p>
         </p:txBody>
@@ -3128,6 +3132,10 @@
             </a:solidFill>
           </a:ln>
         </p:spPr>
+        <p:txBody xmlns:a="http://schemas.openxmlformats.org/drawingml/2006/main">
+          <a:bodyPr/>
+          <a:p/>
+        </p:txBody>
       </p:sp>
       <p:sp>
         <p:nvSpPr>
@@ -3238,7 +3246,7 @@
                 <a:ea typeface="Arial"/>
                 <a:cs typeface="Arial"/>
               </a:rPr>
-              <a:t>Fixture telemetry supplied</a:t>
+              <a:t>Synthetic fixture evidence</a:t>
             </a:r>
           </a:p>
         </p:txBody>
@@ -3331,6 +3339,10 @@
             </a:solidFill>
           </a:ln>
         </p:spPr>
+        <p:txBody xmlns:a="http://schemas.openxmlformats.org/drawingml/2006/main">
+          <a:bodyPr/>
+          <a:p/>
+        </p:txBody>
       </p:sp>
       <p:sp>
         <p:nvSpPr>
@@ -3620,6 +3632,10 @@
             </a:solidFill>
           </a:ln>
         </p:spPr>
+        <p:txBody xmlns:a="http://schemas.openxmlformats.org/drawingml/2006/main">
+          <a:bodyPr/>
+          <a:p/>
+        </p:txBody>
       </p:sp>
       <p:sp>
         <p:nvSpPr>
@@ -4015,7 +4031,7 @@
                 <a:ea typeface="Arial"/>
                 <a:cs typeface="Arial"/>
               </a:rPr>
-              <a:t>Unknown IDs are blocked. There is no network or provider call in the demo.</a:t>
+              <a:t>Unknown IDs are blocked. The demo calls no external AI provider.</a:t>
             </a:r>
           </a:p>
         </p:txBody>
@@ -4051,6 +4067,10 @@
             </a:solidFill>
           </a:ln>
         </p:spPr>
+        <p:txBody xmlns:a="http://schemas.openxmlformats.org/drawingml/2006/main">
+          <a:bodyPr/>
+          <a:p/>
+        </p:txBody>
       </p:sp>
       <p:sp>
         <p:nvSpPr>
@@ -4226,6 +4246,10 @@
             </a:solidFill>
           </a:ln>
         </p:spPr>
+        <p:txBody xmlns:a="http://schemas.openxmlformats.org/drawingml/2006/main">
+          <a:bodyPr/>
+          <a:p/>
+        </p:txBody>
       </p:sp>
       <p:sp>
         <p:nvSpPr>
@@ -4486,6 +4510,10 @@
             </a:solidFill>
           </a:ln>
         </p:spPr>
+        <p:txBody xmlns:a="http://schemas.openxmlformats.org/drawingml/2006/main">
+          <a:bodyPr/>
+          <a:p/>
+        </p:txBody>
       </p:sp>
       <p:sp>
         <p:nvSpPr>
@@ -4539,7 +4567,7 @@
                 <a:ea typeface="Arial"/>
                 <a:cs typeface="Arial"/>
               </a:rPr>
-              <a:t>100 local tests passed</a:t>
+              <a:t>106 local tests passed</a:t>
             </a:r>
           </a:p>
         </p:txBody>
@@ -4596,7 +4624,7 @@
                 <a:ea typeface="Arial"/>
                 <a:cs typeface="Arial"/>
               </a:rPr>
-              <a:t>HTML report reviewed by the user in a browser</a:t>
+              <a:t>All three synthetic states reviewed in a local browser</a:t>
             </a:r>
           </a:p>
         </p:txBody>
@@ -4653,7 +4681,7 @@
                 <a:ea typeface="Arial"/>
                 <a:cs typeface="Arial"/>
               </a:rPr>
-              <a:t>Bob task-session exports must accompany the public submission.</a:t>
+              <a:t>Redacted Bob history and summary screenshot are included in the repository.</a:t>
             </a:r>
           </a:p>
         </p:txBody>
@@ -4775,6 +4803,10 @@
             </a:solidFill>
           </a:ln>
         </p:spPr>
+        <p:txBody xmlns:a="http://schemas.openxmlformats.org/drawingml/2006/main">
+          <a:bodyPr/>
+          <a:p/>
+        </p:txBody>
       </p:sp>
       <p:sp>
         <p:nvSpPr>
@@ -4828,7 +4860,7 @@
                 <a:ea typeface="Arial"/>
                 <a:cs typeface="Arial"/>
               </a:rPr>
-              <a:t>Proved locally</a:t>
+              <a:t>Verified locally</a:t>
             </a:r>
           </a:p>
         </p:txBody>
@@ -4885,7 +4917,7 @@
                 <a:ea typeface="Arial"/>
                 <a:cs typeface="Arial"/>
               </a:rPr>
-              <a:t>Manifest validation, status calculation, safe report rendering, and the registered local check.</a:t>
+              <a:t>Manifest validation, 106-test verification, safe reports, and an allowlisted local check.</a:t>
             </a:r>
           </a:p>
         </p:txBody>
@@ -4942,7 +4974,7 @@
                 <a:ea typeface="Arial"/>
                 <a:cs typeface="Arial"/>
               </a:rPr>
-              <a:t>Still needs evidence</a:t>
+              <a:t>Observed in the hosted demo</a:t>
             </a:r>
           </a:p>
         </p:txBody>
@@ -4999,7 +5031,7 @@
                 <a:ea typeface="Arial"/>
                 <a:cs typeface="Arial"/>
               </a:rPr>
-              <a:t>Public demo access, hosted behavior, provider behavior, and any production claim.</a:t>
+              <a:t>A live synthetic case remained conditional; no commands ran.</a:t>
             </a:r>
           </a:p>
         </p:txBody>
@@ -5035,6 +5067,10 @@
             </a:solidFill>
           </a:ln>
         </p:spPr>
+        <p:txBody xmlns:a="http://schemas.openxmlformats.org/drawingml/2006/main">
+          <a:bodyPr/>
+          <a:p/>
+        </p:txBody>
       </p:sp>
       <p:sp>
         <p:nvSpPr>
@@ -5080,7 +5116,7 @@
               </a:defRPr>
             </a:pPr>
             <a:r>
-              <a:rPr sz="2250" b="1">
+              <a:rPr sz="1800" b="1">
                 <a:solidFill>
                   <a:srgbClr val="11263D"/>
                 </a:solidFill>
@@ -5088,7 +5124,7 @@
                 <a:ea typeface="Arial"/>
                 <a:cs typeface="Arial"/>
               </a:rPr>
-              <a:t>Submission needs a live prototype, public repository, video, and PDF deck.</a:t>
+              <a:t>Still unverified: providers, private-data protections, and production readiness.</a:t>
             </a:r>
           </a:p>
         </p:txBody>
@@ -5137,7 +5173,7 @@
               </a:defRPr>
             </a:pPr>
             <a:r>
-              <a:rPr sz="1800" b="0">
+              <a:rPr sz="1500" b="0">
                 <a:solidFill>
                   <a:srgbClr val="52677B"/>
                 </a:solidFill>
@@ -5145,7 +5181,7 @@
                 <a:ea typeface="Arial"/>
                 <a:cs typeface="Arial"/>
               </a:rPr>
-              <a:t>No hosted URL, Bob export, or submission is claimed here.</a:t>
+              <a:t>Live demo: https://proofline-ibm-g27i974jq-shaurya-s-projects11.vercel.app</a:t>
             </a:r>
           </a:p>
         </p:txBody>

</xml_diff>